<commit_message>
feat: add voice-over MP4 video + all presentation assets
Videos:
- YogeshPortfolio_WithVoice.mp4  (31 MB) — 150-sec MP4 with Microsoft Neural
  TTS voice-over (en-US-AriaNeural, 20 slides x 7.5 sec, AAC 192kbps)
- YogeshPortfolio_150sec.mp4     (28 MB) — original silent 150-sec MP4 export
- YogeshPortfolio_Video.html     (24 KB) — standalone HTML5 Canvas video player

Presentation:
- YogeshPortfolio_Presentation.pptx — updated with 7500ms slide timings

Voice-over pipeline scripts:
- add_voiceover.js    — Node.js: edge-tts TTS + ffmpeg merge pipeline
- generate_video.js   — Node.js: HTML5 Canvas video generator
- Export-VideoFromPPT.ps1 — PowerShell: PowerPoint COM -> MP4 exporter
- export_video.bat    — one-click .bat wrapper for PS export script

Trainer: Eluri Narendra | IBM Granite Agentic AI SDLC
</commit_message>
<xml_diff>
--- a/YogeshPortfolio_Presentation.pptx
+++ b/YogeshPortfolio_Presentation.pptx
@@ -1839,7 +1839,7 @@
 </file>
 
 <file path=ppt/slides/slide1.xml><?xml version="1.0" encoding="utf-8"?>
-<p:sld xmlns:p="http://schemas.openxmlformats.org/presentationml/2006/main">
+<p:sld xmlns:a="http://schemas.openxmlformats.org/drawingml/2006/main" xmlns:p="http://schemas.openxmlformats.org/presentationml/2006/main">
   <p:cSld>
     <p:bg>
       <p:bgPr>
@@ -2123,11 +2123,12 @@
       </p:sp>
     </p:spTree>
   </p:cSld>
+  <p:transition advTm="7500"/>
 </p:sld>
 </file>
 
 <file path=ppt/slides/slide10.xml><?xml version="1.0" encoding="utf-8"?>
-<p:sld xmlns:p="http://schemas.openxmlformats.org/presentationml/2006/main">
+<p:sld xmlns:a="http://schemas.openxmlformats.org/drawingml/2006/main" xmlns:p="http://schemas.openxmlformats.org/presentationml/2006/main">
   <p:cSld>
     <p:bg>
       <p:bgPr>
@@ -2736,11 +2737,12 @@
       </p:sp>
     </p:spTree>
   </p:cSld>
+  <p:transition advTm="7500"/>
 </p:sld>
 </file>
 
 <file path=ppt/slides/slide11.xml><?xml version="1.0" encoding="utf-8"?>
-<p:sld xmlns:p="http://schemas.openxmlformats.org/presentationml/2006/main">
+<p:sld xmlns:a="http://schemas.openxmlformats.org/drawingml/2006/main" xmlns:p="http://schemas.openxmlformats.org/presentationml/2006/main">
   <p:cSld>
     <p:bg>
       <p:bgPr>
@@ -3169,11 +3171,12 @@
       </p:sp>
     </p:spTree>
   </p:cSld>
+  <p:transition advTm="7500"/>
 </p:sld>
 </file>
 
 <file path=ppt/slides/slide12.xml><?xml version="1.0" encoding="utf-8"?>
-<p:sld xmlns:p="http://schemas.openxmlformats.org/presentationml/2006/main">
+<p:sld xmlns:a="http://schemas.openxmlformats.org/drawingml/2006/main" xmlns:p="http://schemas.openxmlformats.org/presentationml/2006/main">
   <p:cSld>
     <p:bg>
       <p:bgPr>
@@ -3805,11 +3808,12 @@
       </p:sp>
     </p:spTree>
   </p:cSld>
+  <p:transition advTm="7500"/>
 </p:sld>
 </file>
 
 <file path=ppt/slides/slide13.xml><?xml version="1.0" encoding="utf-8"?>
-<p:sld xmlns:p="http://schemas.openxmlformats.org/presentationml/2006/main">
+<p:sld xmlns:a="http://schemas.openxmlformats.org/drawingml/2006/main" xmlns:p="http://schemas.openxmlformats.org/presentationml/2006/main">
   <p:cSld>
     <p:bg>
       <p:bgPr>
@@ -4471,11 +4475,12 @@
       </p:sp>
     </p:spTree>
   </p:cSld>
+  <p:transition advTm="7500"/>
 </p:sld>
 </file>
 
 <file path=ppt/slides/slide14.xml><?xml version="1.0" encoding="utf-8"?>
-<p:sld xmlns:p="http://schemas.openxmlformats.org/presentationml/2006/main">
+<p:sld xmlns:a="http://schemas.openxmlformats.org/drawingml/2006/main" xmlns:p="http://schemas.openxmlformats.org/presentationml/2006/main">
   <p:cSld>
     <p:bg>
       <p:bgPr>
@@ -4966,11 +4971,12 @@
       </p:sp>
     </p:spTree>
   </p:cSld>
+  <p:transition advTm="7500"/>
 </p:sld>
 </file>
 
 <file path=ppt/slides/slide15.xml><?xml version="1.0" encoding="utf-8"?>
-<p:sld xmlns:p="http://schemas.openxmlformats.org/presentationml/2006/main">
+<p:sld xmlns:a="http://schemas.openxmlformats.org/drawingml/2006/main" xmlns:p="http://schemas.openxmlformats.org/presentationml/2006/main">
   <p:cSld>
     <p:bg>
       <p:bgPr>
@@ -5471,11 +5477,12 @@
       </p:sp>
     </p:spTree>
   </p:cSld>
+  <p:transition advTm="7500"/>
 </p:sld>
 </file>
 
 <file path=ppt/slides/slide16.xml><?xml version="1.0" encoding="utf-8"?>
-<p:sld xmlns:p="http://schemas.openxmlformats.org/presentationml/2006/main">
+<p:sld xmlns:a="http://schemas.openxmlformats.org/drawingml/2006/main" xmlns:p="http://schemas.openxmlformats.org/presentationml/2006/main">
   <p:cSld>
     <p:bg>
       <p:bgPr>
@@ -6121,11 +6128,12 @@
       </p:sp>
     </p:spTree>
   </p:cSld>
+  <p:transition advTm="7500"/>
 </p:sld>
 </file>
 
 <file path=ppt/slides/slide17.xml><?xml version="1.0" encoding="utf-8"?>
-<p:sld xmlns:p="http://schemas.openxmlformats.org/presentationml/2006/main">
+<p:sld xmlns:a="http://schemas.openxmlformats.org/drawingml/2006/main" xmlns:p="http://schemas.openxmlformats.org/presentationml/2006/main">
   <p:cSld>
     <p:bg>
       <p:bgPr>
@@ -6761,11 +6769,12 @@
       </p:sp>
     </p:spTree>
   </p:cSld>
+  <p:transition advTm="7500"/>
 </p:sld>
 </file>
 
 <file path=ppt/slides/slide18.xml><?xml version="1.0" encoding="utf-8"?>
-<p:sld xmlns:p="http://schemas.openxmlformats.org/presentationml/2006/main">
+<p:sld xmlns:a="http://schemas.openxmlformats.org/drawingml/2006/main" xmlns:p="http://schemas.openxmlformats.org/presentationml/2006/main">
   <p:cSld>
     <p:bg>
       <p:bgPr>
@@ -7128,11 +7137,12 @@
       </p:sp>
     </p:spTree>
   </p:cSld>
+  <p:transition advTm="7500"/>
 </p:sld>
 </file>
 
 <file path=ppt/slides/slide19.xml><?xml version="1.0" encoding="utf-8"?>
-<p:sld xmlns:p="http://schemas.openxmlformats.org/presentationml/2006/main">
+<p:sld xmlns:a="http://schemas.openxmlformats.org/drawingml/2006/main" xmlns:p="http://schemas.openxmlformats.org/presentationml/2006/main">
   <p:cSld>
     <p:bg>
       <p:bgPr>
@@ -7511,11 +7521,12 @@
       </p:sp>
     </p:spTree>
   </p:cSld>
+  <p:transition advTm="7500"/>
 </p:sld>
 </file>
 
 <file path=ppt/slides/slide2.xml><?xml version="1.0" encoding="utf-8"?>
-<p:sld xmlns:p="http://schemas.openxmlformats.org/presentationml/2006/main">
+<p:sld xmlns:a="http://schemas.openxmlformats.org/drawingml/2006/main" xmlns:p="http://schemas.openxmlformats.org/presentationml/2006/main">
   <p:cSld>
     <p:bg>
       <p:bgPr>
@@ -7859,11 +7870,12 @@
       </p:sp>
     </p:spTree>
   </p:cSld>
+  <p:transition advTm="7500"/>
 </p:sld>
 </file>
 
 <file path=ppt/slides/slide20.xml><?xml version="1.0" encoding="utf-8"?>
-<p:sld xmlns:p="http://schemas.openxmlformats.org/presentationml/2006/main">
+<p:sld xmlns:a="http://schemas.openxmlformats.org/drawingml/2006/main" xmlns:p="http://schemas.openxmlformats.org/presentationml/2006/main">
   <p:cSld>
     <p:bg>
       <p:bgPr>
@@ -8392,11 +8404,12 @@
       </p:sp>
     </p:spTree>
   </p:cSld>
+  <p:transition advTm="7500"/>
 </p:sld>
 </file>
 
 <file path=ppt/slides/slide3.xml><?xml version="1.0" encoding="utf-8"?>
-<p:sld xmlns:p="http://schemas.openxmlformats.org/presentationml/2006/main">
+<p:sld xmlns:a="http://schemas.openxmlformats.org/drawingml/2006/main" xmlns:p="http://schemas.openxmlformats.org/presentationml/2006/main">
   <p:cSld>
     <p:bg>
       <p:bgPr>
@@ -8762,11 +8775,12 @@
       </p:sp>
     </p:spTree>
   </p:cSld>
+  <p:transition advTm="7500"/>
 </p:sld>
 </file>
 
 <file path=ppt/slides/slide4.xml><?xml version="1.0" encoding="utf-8"?>
-<p:sld xmlns:p="http://schemas.openxmlformats.org/presentationml/2006/main">
+<p:sld xmlns:a="http://schemas.openxmlformats.org/drawingml/2006/main" xmlns:p="http://schemas.openxmlformats.org/presentationml/2006/main">
   <p:cSld>
     <p:bg>
       <p:bgPr>
@@ -9340,11 +9354,12 @@
       </p:sp>
     </p:spTree>
   </p:cSld>
+  <p:transition advTm="7500"/>
 </p:sld>
 </file>
 
 <file path=ppt/slides/slide5.xml><?xml version="1.0" encoding="utf-8"?>
-<p:sld xmlns:p="http://schemas.openxmlformats.org/presentationml/2006/main">
+<p:sld xmlns:a="http://schemas.openxmlformats.org/drawingml/2006/main" xmlns:p="http://schemas.openxmlformats.org/presentationml/2006/main">
   <p:cSld>
     <p:bg>
       <p:bgPr>
@@ -9728,11 +9743,12 @@
       </p:sp>
     </p:spTree>
   </p:cSld>
+  <p:transition advTm="7500"/>
 </p:sld>
 </file>
 
 <file path=ppt/slides/slide6.xml><?xml version="1.0" encoding="utf-8"?>
-<p:sld xmlns:p="http://schemas.openxmlformats.org/presentationml/2006/main">
+<p:sld xmlns:a="http://schemas.openxmlformats.org/drawingml/2006/main" xmlns:p="http://schemas.openxmlformats.org/presentationml/2006/main">
   <p:cSld>
     <p:bg>
       <p:bgPr>
@@ -10149,11 +10165,12 @@
       </p:sp>
     </p:spTree>
   </p:cSld>
+  <p:transition advTm="7500"/>
 </p:sld>
 </file>
 
 <file path=ppt/slides/slide7.xml><?xml version="1.0" encoding="utf-8"?>
-<p:sld xmlns:p="http://schemas.openxmlformats.org/presentationml/2006/main">
+<p:sld xmlns:a="http://schemas.openxmlformats.org/drawingml/2006/main" xmlns:p="http://schemas.openxmlformats.org/presentationml/2006/main">
   <p:cSld>
     <p:bg>
       <p:bgPr>
@@ -10557,11 +10574,12 @@
       </p:sp>
     </p:spTree>
   </p:cSld>
+  <p:transition advTm="7500"/>
 </p:sld>
 </file>
 
 <file path=ppt/slides/slide8.xml><?xml version="1.0" encoding="utf-8"?>
-<p:sld xmlns:p="http://schemas.openxmlformats.org/presentationml/2006/main">
+<p:sld xmlns:a="http://schemas.openxmlformats.org/drawingml/2006/main" xmlns:p="http://schemas.openxmlformats.org/presentationml/2006/main">
   <p:cSld>
     <p:bg>
       <p:bgPr>
@@ -11148,11 +11166,12 @@
       </p:sp>
     </p:spTree>
   </p:cSld>
+  <p:transition advTm="7500"/>
 </p:sld>
 </file>
 
 <file path=ppt/slides/slide9.xml><?xml version="1.0" encoding="utf-8"?>
-<p:sld xmlns:p="http://schemas.openxmlformats.org/presentationml/2006/main">
+<p:sld xmlns:a="http://schemas.openxmlformats.org/drawingml/2006/main" xmlns:p="http://schemas.openxmlformats.org/presentationml/2006/main">
   <p:cSld>
     <p:bg>
       <p:bgPr>
@@ -11886,6 +11905,7 @@
       </p:sp>
     </p:spTree>
   </p:cSld>
+  <p:transition advTm="7500"/>
 </p:sld>
 </file>
 

</xml_diff>